<commit_message>
Update presentation with axis titles on slides 6, 8, and 10
</commit_message>
<xml_diff>
--- a/notebooks/home_credit_presentation.pptx
+++ b/notebooks/home_credit_presentation.pptx
@@ -530,6 +530,35 @@
         </c:scaling>
         <c:delete val="0"/>
         <c:axPos val="b"/>
+        <c:title>
+          <c:tx>
+            <c:rich>
+              <a:bodyPr/>
+              <a:lstStyle/>
+              <a:p>
+                <a:pPr>
+                  <a:defRPr sz="1200" b="0" i="0" u="none" strike="noStrike">
+                    <a:solidFill>
+                      <a:srgbClr val="1E2761"/>
+                    </a:solidFill>
+                    <a:latin typeface="Arial"/>
+                  </a:defRPr>
+                </a:pPr>
+                <a:r>
+                  <a:rPr sz="1200" b="0" i="0" u="none" strike="noStrike">
+                    <a:solidFill>
+                      <a:srgbClr val="1E2761"/>
+                    </a:solidFill>
+                    <a:latin typeface="Arial"/>
+                  </a:rPr>
+                  <a:t>Model</a:t>
+                </a:r>
+              </a:p>
+            </c:rich>
+          </c:tx>
+          <c:layout/>
+          <c:overlay val="0"/>
+        </c:title>
         <c:numFmt formatCode="General" sourceLinked="1"/>
         <c:majorTickMark val="out"/>
         <c:minorTickMark val="none"/>
@@ -583,6 +612,35 @@
             </a:ln>
           </c:spPr>
         </c:majorGridlines>
+        <c:title>
+          <c:tx>
+            <c:rich>
+              <a:bodyPr/>
+              <a:lstStyle/>
+              <a:p>
+                <a:pPr>
+                  <a:defRPr sz="1200" b="0" i="0" u="none" strike="noStrike">
+                    <a:solidFill>
+                      <a:srgbClr val="1E2761"/>
+                    </a:solidFill>
+                    <a:latin typeface="Arial"/>
+                  </a:defRPr>
+                </a:pPr>
+                <a:r>
+                  <a:rPr sz="1200" b="0" i="0" u="none" strike="noStrike">
+                    <a:solidFill>
+                      <a:srgbClr val="1E2761"/>
+                    </a:solidFill>
+                    <a:latin typeface="Arial"/>
+                  </a:rPr>
+                  <a:t>Validation AUC</a:t>
+                </a:r>
+              </a:p>
+            </c:rich>
+          </c:tx>
+          <c:layout/>
+          <c:overlay val="0"/>
+        </c:title>
         <c:numFmt formatCode="General" sourceLinked="0"/>
         <c:majorTickMark val="out"/>
         <c:minorTickMark val="none"/>
@@ -843,6 +901,35 @@
         </c:scaling>
         <c:delete val="0"/>
         <c:axPos val="b"/>
+        <c:title>
+          <c:tx>
+            <c:rich>
+              <a:bodyPr/>
+              <a:lstStyle/>
+              <a:p>
+                <a:pPr>
+                  <a:defRPr sz="1200" b="0" i="0" u="none" strike="noStrike">
+                    <a:solidFill>
+                      <a:srgbClr val="1E2761"/>
+                    </a:solidFill>
+                    <a:latin typeface="Arial"/>
+                  </a:defRPr>
+                </a:pPr>
+                <a:r>
+                  <a:rPr sz="1200" b="0" i="0" u="none" strike="noStrike">
+                    <a:solidFill>
+                      <a:srgbClr val="1E2761"/>
+                    </a:solidFill>
+                    <a:latin typeface="Arial"/>
+                  </a:rPr>
+                  <a:t>Model</a:t>
+                </a:r>
+              </a:p>
+            </c:rich>
+          </c:tx>
+          <c:layout/>
+          <c:overlay val="0"/>
+        </c:title>
         <c:numFmt formatCode="General" sourceLinked="1"/>
         <c:majorTickMark val="out"/>
         <c:minorTickMark val="none"/>
@@ -896,6 +983,35 @@
             </a:ln>
           </c:spPr>
         </c:majorGridlines>
+        <c:title>
+          <c:tx>
+            <c:rich>
+              <a:bodyPr/>
+              <a:lstStyle/>
+              <a:p>
+                <a:pPr>
+                  <a:defRPr sz="1200" b="0" i="0" u="none" strike="noStrike">
+                    <a:solidFill>
+                      <a:srgbClr val="1E2761"/>
+                    </a:solidFill>
+                    <a:latin typeface="Arial"/>
+                  </a:defRPr>
+                </a:pPr>
+                <a:r>
+                  <a:rPr sz="1200" b="0" i="0" u="none" strike="noStrike">
+                    <a:solidFill>
+                      <a:srgbClr val="1E2761"/>
+                    </a:solidFill>
+                    <a:latin typeface="Arial"/>
+                  </a:rPr>
+                  <a:t>Cross-Validated AUC</a:t>
+                </a:r>
+              </a:p>
+            </c:rich>
+          </c:tx>
+          <c:layout/>
+          <c:overlay val="0"/>
+        </c:title>
         <c:numFmt formatCode="General" sourceLinked="0"/>
         <c:majorTickMark val="out"/>
         <c:minorTickMark val="none"/>
@@ -1100,6 +1216,35 @@
         </c:scaling>
         <c:delete val="0"/>
         <c:axPos val="l"/>
+        <c:title>
+          <c:tx>
+            <c:rich>
+              <a:bodyPr/>
+              <a:lstStyle/>
+              <a:p>
+                <a:pPr>
+                  <a:defRPr sz="1200" b="0" i="0" u="none" strike="noStrike">
+                    <a:solidFill>
+                      <a:srgbClr val="1E2761"/>
+                    </a:solidFill>
+                    <a:latin typeface="Arial"/>
+                  </a:defRPr>
+                </a:pPr>
+                <a:r>
+                  <a:rPr sz="1200" b="0" i="0" u="none" strike="noStrike">
+                    <a:solidFill>
+                      <a:srgbClr val="1E2761"/>
+                    </a:solidFill>
+                    <a:latin typeface="Arial"/>
+                  </a:rPr>
+                  <a:t>Feature</a:t>
+                </a:r>
+              </a:p>
+            </c:rich>
+          </c:tx>
+          <c:layout/>
+          <c:overlay val="0"/>
+        </c:title>
         <c:numFmt formatCode="General" sourceLinked="1"/>
         <c:majorTickMark val="out"/>
         <c:minorTickMark val="none"/>
@@ -1152,6 +1297,35 @@
             </a:ln>
           </c:spPr>
         </c:majorGridlines>
+        <c:title>
+          <c:tx>
+            <c:rich>
+              <a:bodyPr/>
+              <a:lstStyle/>
+              <a:p>
+                <a:pPr>
+                  <a:defRPr sz="1200" b="0" i="0" u="none" strike="noStrike">
+                    <a:solidFill>
+                      <a:srgbClr val="1E2761"/>
+                    </a:solidFill>
+                    <a:latin typeface="Arial"/>
+                  </a:defRPr>
+                </a:pPr>
+                <a:r>
+                  <a:rPr sz="1200" b="0" i="0" u="none" strike="noStrike">
+                    <a:solidFill>
+                      <a:srgbClr val="1E2761"/>
+                    </a:solidFill>
+                    <a:latin typeface="Arial"/>
+                  </a:rPr>
+                  <a:t>Share of Decision Weight (%)</a:t>
+                </a:r>
+              </a:p>
+            </c:rich>
+          </c:tx>
+          <c:layout/>
+          <c:overlay val="0"/>
+        </c:title>
         <c:numFmt formatCode="General" sourceLinked="0"/>
         <c:majorTickMark val="out"/>
         <c:minorTickMark val="none"/>

</xml_diff>